<commit_message>
Bai tap cuoi ky: them phan cong 2 thanh vien va ban PDF
- Phan cong 50/50: Nguyen Quoc Cuong (phan tich bai toan, slide),
  Tran Nhu Duc (code thuat toan, bao cao); members.py dung chung, gen_phancong.py
- Them PDF cho slide va bang phan cong; xuat lai PDF bao cao
- Sua robust_dedup.py doc du lieu goc tu data/ (truoc do doc ban da loai trung,
  lam Bang 5 va bieu do ban ghi trung sai); sua chu chong o slide 6
</commit_message>
<xml_diff>
--- a/bai-tap-cuoi-ky/Slide_NhanDangMau.pptx
+++ b/bai-tap-cuoi-ky/Slide_NhanDangMau.pptx
@@ -478,16 +478,16 @@
                 <c:formatCode>General</c:formatCode>
                 <c:ptCount val="4"/>
                 <c:pt idx="0">
-                  <c:v>0.277</c:v>
+                  <c:v>0.408</c:v>
                 </c:pt>
                 <c:pt idx="1">
-                  <c:v>0.539</c:v>
+                  <c:v>0.586</c:v>
                 </c:pt>
                 <c:pt idx="2">
-                  <c:v>0.45</c:v>
+                  <c:v>0.665</c:v>
                 </c:pt>
                 <c:pt idx="3">
-                  <c:v>0.494</c:v>
+                  <c:v>0.676</c:v>
                 </c:pt>
               </c:numCache>
             </c:numRef>
@@ -5174,7 +5174,23 @@
                 </a:solidFill>
                 <a:latin typeface="Calibri"/>
               </a:rPr>
-              <a:t>Nhóm ….. | Giảng viên: ……</a:t>
+              <a:t>Nguyễn Quốc Cường – Trần Như Đức</a:t>
+            </a:r>
+          </a:p>
+          <a:p>
+            <a:pPr algn="l">
+              <a:spcAft>
+                <a:spcPts val="600"/>
+              </a:spcAft>
+            </a:pPr>
+            <a:r>
+              <a:rPr sz="1600" b="0">
+                <a:solidFill>
+                  <a:srgbClr val="E8C9CF"/>
+                </a:solidFill>
+                <a:latin typeface="Calibri"/>
+              </a:rPr>
+              <a:t>Giảng viên: ……</a:t>
             </a:r>
           </a:p>
         </p:txBody>
@@ -7687,7 +7703,7 @@
         </p:nvGraphicFramePr>
         <p:xfrm>
           <a:off x="548640" y="1463040"/>
-          <a:ext cx="6583680" cy="1920240"/>
+          <a:ext cx="6583680" cy="1152144"/>
         </p:xfrm>
         <a:graphic>
           <a:graphicData uri="http://schemas.openxmlformats.org/drawingml/2006/table">
@@ -7696,9 +7712,9 @@
                 <a:tableStyleId>{5C22544A-7EE6-4342-B048-85BDC9FD1C3A}</a:tableStyleId>
               </a:tblPr>
               <a:tblGrid>
-                <a:gridCol w="2194560"/>
-                <a:gridCol w="3200400"/>
-                <a:gridCol w="1188720"/>
+                <a:gridCol w="2377440"/>
+                <a:gridCol w="3108960"/>
+                <a:gridCol w="1097280"/>
               </a:tblGrid>
               <a:tr h="384048">
                 <a:tc>
@@ -7707,7 +7723,7 @@
                     <a:lstStyle/>
                     <a:p>
                       <a:pPr>
-                        <a:defRPr sz="1400" b="1">
+                        <a:defRPr sz="1600" b="1">
                           <a:solidFill>
                             <a:srgbClr val="FFFFFF"/>
                           </a:solidFill>
@@ -7731,7 +7747,7 @@
                     <a:lstStyle/>
                     <a:p>
                       <a:pPr>
-                        <a:defRPr sz="1400" b="1">
+                        <a:defRPr sz="1600" b="1">
                           <a:solidFill>
                             <a:srgbClr val="FFFFFF"/>
                           </a:solidFill>
@@ -7755,7 +7771,7 @@
                     <a:lstStyle/>
                     <a:p>
                       <a:pPr>
-                        <a:defRPr sz="1400" b="1">
+                        <a:defRPr sz="1600" b="1">
                           <a:solidFill>
                             <a:srgbClr val="FFFFFF"/>
                           </a:solidFill>
@@ -7781,7 +7797,7 @@
                     <a:lstStyle/>
                     <a:p>
                       <a:pPr>
-                        <a:defRPr sz="1400" b="0">
+                        <a:defRPr sz="1600" b="0">
                           <a:solidFill>
                             <a:srgbClr val="2B2024"/>
                           </a:solidFill>
@@ -7789,7 +7805,7 @@
                         </a:defRPr>
                       </a:pPr>
                       <a:r>
-                        <a:t>…… (nhóm trưởng)</a:t>
+                        <a:t>Nguyễn Quốc Cường</a:t>
                       </a:r>
                     </a:p>
                   </a:txBody>
@@ -7805,7 +7821,7 @@
                     <a:lstStyle/>
                     <a:p>
                       <a:pPr>
-                        <a:defRPr sz="1400" b="0">
+                        <a:defRPr sz="1600" b="0">
                           <a:solidFill>
                             <a:srgbClr val="2B2024"/>
                           </a:solidFill>
@@ -7813,7 +7829,7 @@
                         </a:defRPr>
                       </a:pPr>
                       <a:r>
-                        <a:t>EDA, phát hiện bản ghi trùng</a:t>
+                        <a:t>Phân tích bài toán, làm slide</a:t>
                       </a:r>
                     </a:p>
                   </a:txBody>
@@ -7829,7 +7845,7 @@
                     <a:lstStyle/>
                     <a:p>
                       <a:pPr>
-                        <a:defRPr sz="1400" b="0">
+                        <a:defRPr sz="1600" b="0">
                           <a:solidFill>
                             <a:srgbClr val="2B2024"/>
                           </a:solidFill>
@@ -7837,7 +7853,7 @@
                         </a:defRPr>
                       </a:pPr>
                       <a:r>
-                        <a:t>25%</a:t>
+                        <a:t>50%</a:t>
                       </a:r>
                     </a:p>
                   </a:txBody>
@@ -7855,7 +7871,7 @@
                     <a:lstStyle/>
                     <a:p>
                       <a:pPr>
-                        <a:defRPr sz="1400" b="0">
+                        <a:defRPr sz="1600" b="0">
                           <a:solidFill>
                             <a:srgbClr val="2B2024"/>
                           </a:solidFill>
@@ -7863,7 +7879,7 @@
                         </a:defRPr>
                       </a:pPr>
                       <a:r>
-                        <a:t>……</a:t>
+                        <a:t>Trần Như Đức</a:t>
                       </a:r>
                     </a:p>
                   </a:txBody>
@@ -7879,7 +7895,7 @@
                     <a:lstStyle/>
                     <a:p>
                       <a:pPr>
-                        <a:defRPr sz="1400" b="0">
+                        <a:defRPr sz="1600" b="0">
                           <a:solidFill>
                             <a:srgbClr val="2B2024"/>
                           </a:solidFill>
@@ -7887,7 +7903,7 @@
                         </a:defRPr>
                       </a:pPr>
                       <a:r>
-                        <a:t>Cơ sở, tiền xử lý, CV</a:t>
+                        <a:t>Code thuật toán, làm báo cáo</a:t>
                       </a:r>
                     </a:p>
                   </a:txBody>
@@ -7903,7 +7919,7 @@
                     <a:lstStyle/>
                     <a:p>
                       <a:pPr>
-                        <a:defRPr sz="1400" b="0">
+                        <a:defRPr sz="1600" b="0">
                           <a:solidFill>
                             <a:srgbClr val="2B2024"/>
                           </a:solidFill>
@@ -7911,155 +7927,7 @@
                         </a:defRPr>
                       </a:pPr>
                       <a:r>
-                        <a:t>25%</a:t>
-                      </a:r>
-                    </a:p>
-                  </a:txBody>
-                  <a:tcPr>
-                    <a:solidFill>
-                      <a:srgbClr val="FFFFFF"/>
-                    </a:solidFill>
-                  </a:tcPr>
-                </a:tc>
-              </a:tr>
-              <a:tr h="384048">
-                <a:tc>
-                  <a:txBody>
-                    <a:bodyPr/>
-                    <a:lstStyle/>
-                    <a:p>
-                      <a:pPr>
-                        <a:defRPr sz="1400" b="0">
-                          <a:solidFill>
-                            <a:srgbClr val="2B2024"/>
-                          </a:solidFill>
-                          <a:latin typeface="Calibri"/>
-                        </a:defRPr>
-                      </a:pPr>
-                      <a:r>
-                        <a:t>……</a:t>
-                      </a:r>
-                    </a:p>
-                  </a:txBody>
-                  <a:tcPr>
-                    <a:solidFill>
-                      <a:srgbClr val="F6EDEF"/>
-                    </a:solidFill>
-                  </a:tcPr>
-                </a:tc>
-                <a:tc>
-                  <a:txBody>
-                    <a:bodyPr/>
-                    <a:lstStyle/>
-                    <a:p>
-                      <a:pPr>
-                        <a:defRPr sz="1400" b="0">
-                          <a:solidFill>
-                            <a:srgbClr val="2B2024"/>
-                          </a:solidFill>
-                          <a:latin typeface="Calibri"/>
-                        </a:defRPr>
-                      </a:pPr>
-                      <a:r>
-                        <a:t>Cải tiến, kiểm định, phân tích lỗi</a:t>
-                      </a:r>
-                    </a:p>
-                  </a:txBody>
-                  <a:tcPr>
-                    <a:solidFill>
-                      <a:srgbClr val="F6EDEF"/>
-                    </a:solidFill>
-                  </a:tcPr>
-                </a:tc>
-                <a:tc>
-                  <a:txBody>
-                    <a:bodyPr/>
-                    <a:lstStyle/>
-                    <a:p>
-                      <a:pPr>
-                        <a:defRPr sz="1400" b="0">
-                          <a:solidFill>
-                            <a:srgbClr val="2B2024"/>
-                          </a:solidFill>
-                          <a:latin typeface="Calibri"/>
-                        </a:defRPr>
-                      </a:pPr>
-                      <a:r>
-                        <a:t>25%</a:t>
-                      </a:r>
-                    </a:p>
-                  </a:txBody>
-                  <a:tcPr>
-                    <a:solidFill>
-                      <a:srgbClr val="F6EDEF"/>
-                    </a:solidFill>
-                  </a:tcPr>
-                </a:tc>
-              </a:tr>
-              <a:tr h="384048">
-                <a:tc>
-                  <a:txBody>
-                    <a:bodyPr/>
-                    <a:lstStyle/>
-                    <a:p>
-                      <a:pPr>
-                        <a:defRPr sz="1400" b="0">
-                          <a:solidFill>
-                            <a:srgbClr val="2B2024"/>
-                          </a:solidFill>
-                          <a:latin typeface="Calibri"/>
-                        </a:defRPr>
-                      </a:pPr>
-                      <a:r>
-                        <a:t>……</a:t>
-                      </a:r>
-                    </a:p>
-                  </a:txBody>
-                  <a:tcPr>
-                    <a:solidFill>
-                      <a:srgbClr val="FFFFFF"/>
-                    </a:solidFill>
-                  </a:tcPr>
-                </a:tc>
-                <a:tc>
-                  <a:txBody>
-                    <a:bodyPr/>
-                    <a:lstStyle/>
-                    <a:p>
-                      <a:pPr>
-                        <a:defRPr sz="1400" b="0">
-                          <a:solidFill>
-                            <a:srgbClr val="2B2024"/>
-                          </a:solidFill>
-                          <a:latin typeface="Calibri"/>
-                        </a:defRPr>
-                      </a:pPr>
-                      <a:r>
-                        <a:t>Demo, báo cáo, slide</a:t>
-                      </a:r>
-                    </a:p>
-                  </a:txBody>
-                  <a:tcPr>
-                    <a:solidFill>
-                      <a:srgbClr val="FFFFFF"/>
-                    </a:solidFill>
-                  </a:tcPr>
-                </a:tc>
-                <a:tc>
-                  <a:txBody>
-                    <a:bodyPr/>
-                    <a:lstStyle/>
-                    <a:p>
-                      <a:pPr>
-                        <a:defRPr sz="1400" b="0">
-                          <a:solidFill>
-                            <a:srgbClr val="2B2024"/>
-                          </a:solidFill>
-                          <a:latin typeface="Calibri"/>
-                        </a:defRPr>
-                      </a:pPr>
-                      <a:r>
-                        <a:t>25%</a:t>
+                        <a:t>50%</a:t>
                       </a:r>
                     </a:p>
                   </a:txBody>
@@ -10351,7 +10219,7 @@
                 </a:solidFill>
                 <a:latin typeface="Calibri"/>
               </a:rPr>
-              <a:t>SVR thứ bậc: 0,570</a:t>
+              <a:t>0,570</a:t>
             </a:r>
           </a:p>
         </p:txBody>
@@ -10390,7 +10258,7 @@
                 </a:solidFill>
                 <a:latin typeface="Calibri"/>
               </a:rPr>
-              <a:t>F1 cao nhất; mọi cải tiến p &lt; 0,001</a:t>
+              <a:t>F1 cao nhất: SVR thứ bậc; mọi cải tiến p &lt; 0,001</a:t>
             </a:r>
           </a:p>
         </p:txBody>
@@ -10660,7 +10528,7 @@
                         </a:defRPr>
                       </a:pPr>
                       <a:r>
-                        <a:t>81.0%</a:t>
+                        <a:t>81,0%</a:t>
                       </a:r>
                     </a:p>
                   </a:txBody>
@@ -10684,7 +10552,7 @@
                         </a:defRPr>
                       </a:pPr>
                       <a:r>
-                        <a:t>0.0%</a:t>
+                        <a:t>0,0%</a:t>
                       </a:r>
                     </a:p>
                   </a:txBody>
@@ -10758,7 +10626,7 @@
                         </a:defRPr>
                       </a:pPr>
                       <a:r>
-                        <a:t>79.2%</a:t>
+                        <a:t>79,2%</a:t>
                       </a:r>
                     </a:p>
                   </a:txBody>
@@ -10782,7 +10650,7 @@
                         </a:defRPr>
                       </a:pPr>
                       <a:r>
-                        <a:t>21.0%</a:t>
+                        <a:t>21,0%</a:t>
                       </a:r>
                     </a:p>
                   </a:txBody>
@@ -10856,7 +10724,7 @@
                         </a:defRPr>
                       </a:pPr>
                       <a:r>
-                        <a:t>83.4%</a:t>
+                        <a:t>83,4%</a:t>
                       </a:r>
                     </a:p>
                   </a:txBody>
@@ -10880,7 +10748,7 @@
                         </a:defRPr>
                       </a:pPr>
                       <a:r>
-                        <a:t>36.2%</a:t>
+                        <a:t>36,2%</a:t>
                       </a:r>
                     </a:p>
                   </a:txBody>
@@ -10954,7 +10822,7 @@
                         </a:defRPr>
                       </a:pPr>
                       <a:r>
-                        <a:t>74.7%</a:t>
+                        <a:t>74,7%</a:t>
                       </a:r>
                     </a:p>
                   </a:txBody>
@@ -10978,7 +10846,7 @@
                         </a:defRPr>
                       </a:pPr>
                       <a:r>
-                        <a:t>80.9%</a:t>
+                        <a:t>80,9%</a:t>
                       </a:r>
                     </a:p>
                   </a:txBody>

</xml_diff>

<commit_message>
Bai tap cuoi ky: thong tin hoc vien/GVHD, minh hoa dong bien phan lop
- Bia bao cao, slide, bang phan cong: Hoc vien Cong nghe Buu chinh Vien thong,
  GVHD Nguyen Xuan Duc, MSSV Tran Nhu Duc B26CHKH027; bo dong Khoa
- Bang phan cong: bo phan ky ten; xuat lai PDF
- gen_viz.py: bien quyet dinh 6 mo hinh tren do con va axit bay hoi,
  sinh figures/phan_lop_dong.gif va trang tuong tac viz/PhanLop_Dong.html
- README: them anh GIF va mo ta
</commit_message>
<xml_diff>
--- a/bai-tap-cuoi-ky/Slide_NhanDangMau.pptx
+++ b/bai-tap-cuoi-ky/Slide_NhanDangMau.pptx
@@ -5158,7 +5158,7 @@
                 </a:solidFill>
                 <a:latin typeface="Calibri"/>
               </a:rPr>
-              <a:t>Bài tập nhóm cuối kỳ – Học phần Nhận dạng mẫu</a:t>
+              <a:t>Bài tập nhóm cuối kỳ – Học phần Nhận dạng mẫu – Học viện Công nghệ Bưu chính Viễn thông</a:t>
             </a:r>
           </a:p>
           <a:p>
@@ -5190,7 +5190,7 @@
                 </a:solidFill>
                 <a:latin typeface="Calibri"/>
               </a:rPr>
-              <a:t>Giảng viên: ……</a:t>
+              <a:t>Giảng viên hướng dẫn: Nguyễn Xuân Đức</a:t>
             </a:r>
           </a:p>
         </p:txBody>

</xml_diff>